<commit_message>
Add slide 29 with Harvard-style references as final slide
</commit_message>
<xml_diff>
--- a/documents_aug2026/AVM_MORGAN_SECURITY_KEYNOTE_30MIN.pptx
+++ b/documents_aug2026/AVM_MORGAN_SECURITY_KEYNOTE_30MIN.pptx
@@ -33,6 +33,7 @@
     <p:sldId id="281" r:id="rId27"/>
     <p:sldId id="282" r:id="rId28"/>
     <p:sldId id="283" r:id="rId33"/>
+    <p:sldId id="284" r:id="rId34"/>
   </p:sldIdLst>
   <p:sldSz cx="12192000" cy="6858000"/>
   <p:notesSz cx="6858000" cy="9144000"/>
@@ -17676,7 +17677,7 @@
                 </a:solidFill>
                 <a:latin typeface="Calibri"/>
               </a:rPr>
-              <a:t>28 / 28</a:t>
+              <a:t>28 / 29</a:t>
             </a:r>
           </a:p>
         </p:txBody>
@@ -17898,6 +17899,566 @@
                 </a:solidFill>
               </a:rPr>
               <a:t>13.  North-Central Nigeria Governors' Forum joint security operations agreement, 2025.</a:t>
+            </a:r>
+          </a:p>
+        </p:txBody>
+      </p:sp>
+    </p:spTree>
+  </p:cSld>
+  <p:clrMapOvr>
+    <a:masterClrMapping/>
+  </p:clrMapOvr>
+</p:sld>
+</file>
+
+<file path=ppt/slides/slide29.xml><?xml version="1.0" encoding="utf-8"?>
+<p:sld xmlns:a="http://schemas.openxmlformats.org/drawingml/2006/main" xmlns:p="http://schemas.openxmlformats.org/presentationml/2006/main" xmlns:r="http://schemas.openxmlformats.org/officeDocument/2006/relationships">
+  <p:cSld>
+    <p:spTree>
+      <p:nvGrpSpPr>
+        <p:cNvPr id="1" name=""/>
+        <p:cNvGrpSpPr/>
+        <p:nvPr/>
+      </p:nvGrpSpPr>
+      <p:grpSpPr/>
+      <p:sp>
+        <p:nvSpPr>
+          <p:cNvPr id="2" name="Rectangle 1"/>
+          <p:cNvSpPr/>
+          <p:nvPr/>
+        </p:nvSpPr>
+        <p:spPr>
+          <a:xfrm>
+            <a:off x="0" y="0"/>
+            <a:ext cx="12191695" cy="1051560"/>
+          </a:xfrm>
+          <a:prstGeom prst="rect">
+            <a:avLst/>
+          </a:prstGeom>
+          <a:solidFill>
+            <a:srgbClr val="132C52"/>
+          </a:solidFill>
+          <a:ln>
+            <a:noFill/>
+          </a:ln>
+          <a:effectLst/>
+        </p:spPr>
+        <p:style>
+          <a:lnRef idx="1">
+            <a:schemeClr val="accent1"/>
+          </a:lnRef>
+          <a:fillRef idx="3">
+            <a:schemeClr val="accent1"/>
+          </a:fillRef>
+          <a:effectRef idx="2">
+            <a:schemeClr val="accent1"/>
+          </a:effectRef>
+          <a:fontRef idx="minor">
+            <a:schemeClr val="lt1"/>
+          </a:fontRef>
+        </p:style>
+        <p:txBody>
+          <a:bodyPr rtlCol="0" anchor="ctr"/>
+          <a:lstStyle/>
+          <a:p>
+            <a:pPr algn="ctr"/>
+            <a:endParaRPr/>
+          </a:p>
+        </p:txBody>
+      </p:sp>
+      <p:sp>
+        <p:nvSpPr>
+          <p:cNvPr id="3" name="Rectangle 2"/>
+          <p:cNvSpPr/>
+          <p:nvPr/>
+        </p:nvSpPr>
+        <p:spPr>
+          <a:xfrm>
+            <a:off x="0" y="1051560"/>
+            <a:ext cx="12191695" cy="38100"/>
+          </a:xfrm>
+          <a:prstGeom prst="rect">
+            <a:avLst/>
+          </a:prstGeom>
+          <a:solidFill>
+            <a:srgbClr val="D4AF37"/>
+          </a:solidFill>
+          <a:ln>
+            <a:noFill/>
+          </a:ln>
+          <a:effectLst/>
+        </p:spPr>
+        <p:style>
+          <a:lnRef idx="1">
+            <a:schemeClr val="accent1"/>
+          </a:lnRef>
+          <a:fillRef idx="3">
+            <a:schemeClr val="accent1"/>
+          </a:fillRef>
+          <a:effectRef idx="2">
+            <a:schemeClr val="accent1"/>
+          </a:effectRef>
+          <a:fontRef idx="minor">
+            <a:schemeClr val="lt1"/>
+          </a:fontRef>
+        </p:style>
+        <p:txBody>
+          <a:bodyPr rtlCol="0" anchor="ctr"/>
+          <a:lstStyle/>
+          <a:p>
+            <a:pPr algn="ctr"/>
+            <a:endParaRPr/>
+          </a:p>
+        </p:txBody>
+      </p:sp>
+      <p:sp>
+        <p:nvSpPr>
+          <p:cNvPr id="4" name="TextBox 3"/>
+          <p:cNvSpPr txBox="1"/>
+          <p:nvPr/>
+        </p:nvSpPr>
+        <p:spPr>
+          <a:xfrm>
+            <a:off x="457200" y="73152"/>
+            <a:ext cx="9144000" cy="320040"/>
+          </a:xfrm>
+          <a:prstGeom prst="rect">
+            <a:avLst/>
+          </a:prstGeom>
+          <a:noFill/>
+        </p:spPr>
+        <p:txBody>
+          <a:bodyPr wrap="square" anchor="t">
+            <a:spAutoFit/>
+          </a:bodyPr>
+          <a:lstStyle/>
+          <a:p>
+            <a:pPr algn="l">
+              <a:lnSpc>
+                <a:spcPct val="110000"/>
+              </a:lnSpc>
+            </a:pPr>
+            <a:r>
+              <a:rPr sz="2000" b="1" i="0">
+                <a:solidFill>
+                  <a:srgbClr val="D4AF37"/>
+                </a:solidFill>
+                <a:latin typeface="Calibri"/>
+              </a:rPr>
+              <a:t>APPENDIX</a:t>
+            </a:r>
+          </a:p>
+        </p:txBody>
+      </p:sp>
+      <p:sp>
+        <p:nvSpPr>
+          <p:cNvPr id="5" name="TextBox 4"/>
+          <p:cNvSpPr txBox="1"/>
+          <p:nvPr/>
+        </p:nvSpPr>
+        <p:spPr>
+          <a:xfrm>
+            <a:off x="457200" y="365760"/>
+            <a:ext cx="10515600" cy="594360"/>
+          </a:xfrm>
+          <a:prstGeom prst="rect">
+            <a:avLst/>
+          </a:prstGeom>
+          <a:noFill/>
+        </p:spPr>
+        <p:txBody>
+          <a:bodyPr wrap="square" anchor="t">
+            <a:spAutoFit/>
+          </a:bodyPr>
+          <a:lstStyle/>
+          <a:p>
+            <a:pPr algn="l">
+              <a:lnSpc>
+                <a:spcPct val="110000"/>
+              </a:lnSpc>
+            </a:pPr>
+            <a:r>
+              <a:rPr sz="2600" b="1" i="0">
+                <a:solidFill>
+                  <a:srgbClr val="FFFFFF"/>
+                </a:solidFill>
+                <a:latin typeface="Calibri"/>
+              </a:rPr>
+              <a:t>References (Harvard Style)</a:t>
+            </a:r>
+          </a:p>
+        </p:txBody>
+      </p:sp>
+      <p:sp>
+        <p:nvSpPr>
+          <p:cNvPr id="6" name="TextBox 5"/>
+          <p:cNvSpPr txBox="1"/>
+          <p:nvPr/>
+        </p:nvSpPr>
+        <p:spPr>
+          <a:xfrm>
+            <a:off x="11247120" y="384048"/>
+            <a:ext cx="731520" cy="457200"/>
+          </a:xfrm>
+          <a:prstGeom prst="rect">
+            <a:avLst/>
+          </a:prstGeom>
+          <a:noFill/>
+        </p:spPr>
+        <p:txBody>
+          <a:bodyPr wrap="square" anchor="t">
+            <a:spAutoFit/>
+          </a:bodyPr>
+          <a:lstStyle/>
+          <a:p>
+            <a:pPr algn="r">
+              <a:lnSpc>
+                <a:spcPct val="110000"/>
+              </a:lnSpc>
+            </a:pPr>
+            <a:r>
+              <a:rPr sz="2000" b="1" i="0">
+                <a:solidFill>
+                  <a:srgbClr val="D4AF37"/>
+                </a:solidFill>
+                <a:latin typeface="Calibri"/>
+              </a:rPr>
+              <a:t>29</a:t>
+            </a:r>
+          </a:p>
+        </p:txBody>
+      </p:sp>
+      <p:sp>
+        <p:nvSpPr>
+          <p:cNvPr id="7" name="TextBox 6"/>
+          <p:cNvSpPr txBox="1"/>
+          <p:nvPr/>
+        </p:nvSpPr>
+        <p:spPr>
+          <a:xfrm>
+            <a:off x="457200" y="6537960"/>
+            <a:ext cx="5486400" cy="274320"/>
+          </a:xfrm>
+          <a:prstGeom prst="rect">
+            <a:avLst/>
+          </a:prstGeom>
+          <a:noFill/>
+        </p:spPr>
+        <p:txBody>
+          <a:bodyPr wrap="square" anchor="t">
+            <a:spAutoFit/>
+          </a:bodyPr>
+          <a:lstStyle/>
+          <a:p>
+            <a:pPr algn="l">
+              <a:lnSpc>
+                <a:spcPct val="110000"/>
+              </a:lnSpc>
+            </a:pPr>
+            <a:r>
+              <a:rPr sz="2000" b="0" i="0">
+                <a:solidFill>
+                  <a:srgbClr val="9AA5B1"/>
+                </a:solidFill>
+                <a:latin typeface="Calibri"/>
+              </a:rPr>
+              <a:t>AVM Monday Riku Morgan (Rtd) — North-Central Security Summit</a:t>
+            </a:r>
+          </a:p>
+        </p:txBody>
+      </p:sp>
+      <p:sp>
+        <p:nvSpPr>
+          <p:cNvPr id="8" name="TextBox 7"/>
+          <p:cNvSpPr txBox="1"/>
+          <p:nvPr/>
+        </p:nvSpPr>
+        <p:spPr>
+          <a:xfrm>
+            <a:off x="10515600" y="6537960"/>
+            <a:ext cx="1280160" cy="274320"/>
+          </a:xfrm>
+          <a:prstGeom prst="rect">
+            <a:avLst/>
+          </a:prstGeom>
+          <a:noFill/>
+        </p:spPr>
+        <p:txBody>
+          <a:bodyPr wrap="square" anchor="t">
+            <a:spAutoFit/>
+          </a:bodyPr>
+          <a:lstStyle/>
+          <a:p>
+            <a:pPr algn="r">
+              <a:lnSpc>
+                <a:spcPct val="110000"/>
+              </a:lnSpc>
+            </a:pPr>
+            <a:r>
+              <a:rPr sz="2000" b="0" i="0">
+                <a:solidFill>
+                  <a:srgbClr val="9AA5B1"/>
+                </a:solidFill>
+                <a:latin typeface="Calibri"/>
+              </a:rPr>
+              <a:t>29 / 29</a:t>
+            </a:r>
+          </a:p>
+        </p:txBody>
+      </p:sp>
+      <p:sp>
+        <p:nvSpPr>
+          <p:cNvPr id="10" name="TextBox 9"/>
+          <p:cNvSpPr txBox="1"/>
+          <p:nvPr/>
+        </p:nvSpPr>
+        <p:spPr>
+          <a:xfrm>
+            <a:off x="457200" y="1280160"/>
+            <a:ext cx="11276395" cy="5074920"/>
+          </a:xfrm>
+          <a:prstGeom prst="rect">
+            <a:avLst/>
+          </a:prstGeom>
+          <a:noFill/>
+        </p:spPr>
+        <p:txBody>
+          <a:bodyPr wrap="square">
+            <a:spAutoFit/>
+          </a:bodyPr>
+          <a:lstStyle/>
+          <a:p>
+            <a:pPr>
+              <a:lnSpc>
+                <a:spcPct val="105000"/>
+              </a:lnSpc>
+              <a:spcAft>
+                <a:spcPts val="1000"/>
+              </a:spcAft>
+            </a:pPr>
+            <a:r>
+              <a:rPr sz="1050">
+                <a:solidFill>
+                  <a:srgbClr val="FFFFFF"/>
+                </a:solidFill>
+              </a:rPr>
+              <a:t>ACLED (2026) Armed Conflict Location &amp; Event Data Project: Nigeria Regional Data, Benue, Plateau and Niger States, 2024-2025. Available at: https://acleddata.com (Accessed: 18 August 2026).</a:t>
+            </a:r>
+          </a:p>
+          <a:p>
+            <a:pPr>
+              <a:lnSpc>
+                <a:spcPct val="105000"/>
+              </a:lnSpc>
+              <a:spcAft>
+                <a:spcPts val="700"/>
+              </a:spcAft>
+            </a:pPr>
+            <a:r>
+              <a:rPr sz="1050">
+                <a:solidFill>
+                  <a:srgbClr val="FFFFFF"/>
+                </a:solidFill>
+              </a:rPr>
+              <a:t>Federal Government of Nigeria (2026) Northern Nigerian Security Trust Fund: Inauguration Statement, July 2026. Abuja: Office of the National Security Adviser.</a:t>
+            </a:r>
+          </a:p>
+          <a:p>
+            <a:pPr>
+              <a:lnSpc>
+                <a:spcPct val="105000"/>
+              </a:lnSpc>
+              <a:spcAft>
+                <a:spcPts val="700"/>
+              </a:spcAft>
+            </a:pPr>
+            <a:r>
+              <a:rPr sz="1050">
+                <a:solidFill>
+                  <a:srgbClr val="FFFFFF"/>
+                </a:solidFill>
+              </a:rPr>
+              <a:t>Government of Colombia, Ministry of Defence (2016) Plan Colombia: Lessons Learned in Community Intelligence and Reintegration. Bogotá: Ministry of Defence.</a:t>
+            </a:r>
+          </a:p>
+          <a:p>
+            <a:pPr>
+              <a:lnSpc>
+                <a:spcPct val="105000"/>
+              </a:lnSpc>
+              <a:spcAft>
+                <a:spcPts val="700"/>
+              </a:spcAft>
+            </a:pPr>
+            <a:r>
+              <a:rPr sz="1050">
+                <a:solidFill>
+                  <a:srgbClr val="FFFFFF"/>
+                </a:solidFill>
+              </a:rPr>
+              <a:t>Government of Kenya, Ministry of Interior and Coordination of National Government (2013) Nyumba Kumi Community Policing Initiative. Nairobi: Government Printer.</a:t>
+            </a:r>
+          </a:p>
+          <a:p>
+            <a:pPr>
+              <a:lnSpc>
+                <a:spcPct val="105000"/>
+              </a:lnSpc>
+              <a:spcAft>
+                <a:spcPts val="700"/>
+              </a:spcAft>
+            </a:pPr>
+            <a:r>
+              <a:rPr sz="1050">
+                <a:solidFill>
+                  <a:srgbClr val="FFFFFF"/>
+                </a:solidFill>
+              </a:rPr>
+              <a:t>Government of the Philippines, Department of the Interior and Local Government (2010) Barangay Peacekeeping Action Teams: Community-Based Security Handbook. Manila: DILG.</a:t>
+            </a:r>
+          </a:p>
+          <a:p>
+            <a:pPr>
+              <a:lnSpc>
+                <a:spcPct val="105000"/>
+              </a:lnSpc>
+              <a:spcAft>
+                <a:spcPts val="700"/>
+              </a:spcAft>
+            </a:pPr>
+            <a:r>
+              <a:rPr sz="1050">
+                <a:solidFill>
+                  <a:srgbClr val="FFFFFF"/>
+                </a:solidFill>
+              </a:rPr>
+              <a:t>HM Government, Home Office (2015) Joint Terrorism Analysis Centre (JTAC): Roles and Responsibilities. London: The Stationery Office.</a:t>
+            </a:r>
+          </a:p>
+          <a:p>
+            <a:pPr>
+              <a:lnSpc>
+                <a:spcPct val="105000"/>
+              </a:lnSpc>
+              <a:spcAft>
+                <a:spcPts val="700"/>
+              </a:spcAft>
+            </a:pPr>
+            <a:r>
+              <a:rPr sz="1050">
+                <a:solidFill>
+                  <a:srgbClr val="FFFFFF"/>
+                </a:solidFill>
+              </a:rPr>
+              <a:t>Office of the Director of National Intelligence (2021) National Counterterrorism Center: Mission and Structure. Washington, DC: ODNI.</a:t>
+            </a:r>
+          </a:p>
+          <a:p>
+            <a:pPr>
+              <a:lnSpc>
+                <a:spcPct val="105000"/>
+              </a:lnSpc>
+              <a:spcAft>
+                <a:spcPts val="700"/>
+              </a:spcAft>
+            </a:pPr>
+            <a:r>
+              <a:rPr sz="1050">
+                <a:solidFill>
+                  <a:srgbClr val="FFFFFF"/>
+                </a:solidFill>
+              </a:rPr>
+              <a:t>Government of India, Ministry of Home Affairs (2009) Multi-Agency Centre (MAC): Post-26/11 Intelligence Reform. New Delhi: Government of India Press.</a:t>
+            </a:r>
+          </a:p>
+          <a:p>
+            <a:pPr>
+              <a:lnSpc>
+                <a:spcPct val="105000"/>
+              </a:lnSpc>
+              <a:spcAft>
+                <a:spcPts val="700"/>
+              </a:spcAft>
+            </a:pPr>
+            <a:r>
+              <a:rPr sz="1050">
+                <a:solidFill>
+                  <a:srgbClr val="FFFFFF"/>
+                </a:solidFill>
+              </a:rPr>
+              <a:t>Israel Ministry of Defence, Home Front Command (2018) Civil Defence Rapid-Response Doctrine. Tel Aviv: Ministry of Defence.</a:t>
+            </a:r>
+          </a:p>
+          <a:p>
+            <a:pPr>
+              <a:lnSpc>
+                <a:spcPct val="105000"/>
+              </a:lnSpc>
+              <a:spcAft>
+                <a:spcPts val="700"/>
+              </a:spcAft>
+            </a:pPr>
+            <a:r>
+              <a:rPr sz="1050">
+                <a:solidFill>
+                  <a:srgbClr val="FFFFFF"/>
+                </a:solidFill>
+              </a:rPr>
+              <a:t>Office of the First Minister and Deputy First Minister (2007) Good Friday Agreement Youth Reintegration Programmes: A Review. Belfast: OFMDFM.</a:t>
+            </a:r>
+          </a:p>
+          <a:p>
+            <a:pPr>
+              <a:lnSpc>
+                <a:spcPct val="105000"/>
+              </a:lnSpc>
+              <a:spcAft>
+                <a:spcPts val="700"/>
+              </a:spcAft>
+            </a:pPr>
+            <a:r>
+              <a:rPr sz="1050">
+                <a:solidFill>
+                  <a:srgbClr val="FFFFFF"/>
+                </a:solidFill>
+              </a:rPr>
+              <a:t>Civilian Secretariat for Police Service, Republic of South Africa (2019) Provincial Policing Powers: Constitutional Review Discussion Paper. Pretoria: Government Printer.</a:t>
+            </a:r>
+          </a:p>
+          <a:p>
+            <a:pPr>
+              <a:lnSpc>
+                <a:spcPct val="105000"/>
+              </a:lnSpc>
+              <a:spcAft>
+                <a:spcPts val="700"/>
+              </a:spcAft>
+            </a:pPr>
+            <a:r>
+              <a:rPr sz="1050">
+                <a:solidFill>
+                  <a:srgbClr val="FFFFFF"/>
+                </a:solidFill>
+              </a:rPr>
+              <a:t>Food and Agriculture Organization of the United Nations (2020) Cross-Border Grazing and Pastoralist Dialogue in the Sahel and Horn of Africa. Rome: FAO.</a:t>
+            </a:r>
+          </a:p>
+          <a:p>
+            <a:pPr>
+              <a:lnSpc>
+                <a:spcPct val="105000"/>
+              </a:lnSpc>
+              <a:spcAft>
+                <a:spcPts val="700"/>
+              </a:spcAft>
+            </a:pPr>
+            <a:r>
+              <a:rPr sz="1050">
+                <a:solidFill>
+                  <a:srgbClr val="FFFFFF"/>
+                </a:solidFill>
+              </a:rPr>
+              <a:t>North-Central Nigeria Governors' Forum (2025) Joint Security Operations Agreement. Minna: North-Central Governors' Forum Secretariat.</a:t>
             </a:r>
           </a:p>
         </p:txBody>

</xml_diff>

<commit_message>
Slide 28: Harvard-style references matching speech doc, 28 slides total (removed separate 29th slide)
</commit_message>
<xml_diff>
--- a/documents_aug2026/AVM_MORGAN_SECURITY_KEYNOTE_30MIN.pptx
+++ b/documents_aug2026/AVM_MORGAN_SECURITY_KEYNOTE_30MIN.pptx
@@ -33,7 +33,6 @@
     <p:sldId id="281" r:id="rId27"/>
     <p:sldId id="282" r:id="rId28"/>
     <p:sldId id="283" r:id="rId33"/>
-    <p:sldId id="284" r:id="rId34"/>
   </p:sldIdLst>
   <p:sldSz cx="12192000" cy="6858000"/>
   <p:notesSz cx="6858000" cy="9144000"/>
@@ -17560,7 +17559,7 @@
                 </a:solidFill>
                 <a:latin typeface="Calibri"/>
               </a:rPr>
-              <a:t>References</a:t>
+              <a:t>References (Harvard Style)</a:t>
             </a:r>
           </a:p>
         </p:txBody>
@@ -17677,531 +17676,7 @@
                 </a:solidFill>
                 <a:latin typeface="Calibri"/>
               </a:rPr>
-              <a:t>28 / 29</a:t>
-            </a:r>
-          </a:p>
-        </p:txBody>
-      </p:sp>
-      <p:sp>
-        <p:nvSpPr>
-          <p:cNvPr id="10" name="TextBox 9"/>
-          <p:cNvSpPr txBox="1"/>
-          <p:nvPr/>
-        </p:nvSpPr>
-        <p:spPr>
-          <a:xfrm>
-            <a:off x="457200" y="1508760"/>
-            <a:ext cx="11276395" cy="4800600"/>
-          </a:xfrm>
-          <a:prstGeom prst="rect">
-            <a:avLst/>
-          </a:prstGeom>
-          <a:noFill/>
-        </p:spPr>
-        <p:txBody>
-          <a:bodyPr wrap="square">
-            <a:spAutoFit/>
-          </a:bodyPr>
-          <a:lstStyle/>
-          <a:p>
-            <a:pPr>
-              <a:lnSpc>
-                <a:spcPct val="115000"/>
-              </a:lnSpc>
-              <a:spcAft>
-                <a:spcPts val="1000"/>
-              </a:spcAft>
-            </a:pPr>
-            <a:r>
-              <a:rPr sz="2000">
-                <a:solidFill>
-                  <a:srgbClr val="FFFFFF"/>
-                </a:solidFill>
-              </a:rPr>
-              <a:t>1.  Armed Conflict Location and Event Data Project (ACLED) — conflict and fatality data, Benue, Plateau and Niger States, January 2024 to December 2025.</a:t>
-            </a:r>
-          </a:p>
-          <a:p>
-            <a:pPr>
-              <a:spcAft>
-                <a:spcPts val="600"/>
-              </a:spcAft>
-            </a:pPr>
-            <a:r>
-              <a:rPr sz="1100">
-                <a:solidFill>
-                  <a:srgbClr val="FFFFFF"/>
-                </a:solidFill>
-              </a:rPr>
-              <a:t>2.  Northern Nigerian Security Trust Fund — inaugurated July 2026.</a:t>
-            </a:r>
-          </a:p>
-          <a:p>
-            <a:pPr>
-              <a:spcAft>
-                <a:spcPts val="600"/>
-              </a:spcAft>
-            </a:pPr>
-            <a:r>
-              <a:rPr sz="1100">
-                <a:solidFill>
-                  <a:srgbClr val="FFFFFF"/>
-                </a:solidFill>
-              </a:rPr>
-              <a:t>3.  Plan Colombia and associated community-intelligence and reintegration programmes, Colombia, 1990s to 2000s.</a:t>
-            </a:r>
-          </a:p>
-          <a:p>
-            <a:pPr>
-              <a:spcAft>
-                <a:spcPts val="600"/>
-              </a:spcAft>
-            </a:pPr>
-            <a:r>
-              <a:rPr sz="1100">
-                <a:solidFill>
-                  <a:srgbClr val="FFFFFF"/>
-                </a:solidFill>
-              </a:rPr>
-              <a:t>4.  Nyumba Kumi community policing initiative, Kenya.</a:t>
-            </a:r>
-          </a:p>
-          <a:p>
-            <a:pPr>
-              <a:spcAft>
-                <a:spcPts val="600"/>
-              </a:spcAft>
-            </a:pPr>
-            <a:r>
-              <a:rPr sz="1100">
-                <a:solidFill>
-                  <a:srgbClr val="FFFFFF"/>
-                </a:solidFill>
-              </a:rPr>
-              <a:t>5.  Barangay Peacekeeping Action Teams, Philippines.</a:t>
-            </a:r>
-          </a:p>
-          <a:p>
-            <a:pPr>
-              <a:spcAft>
-                <a:spcPts val="600"/>
-              </a:spcAft>
-            </a:pPr>
-            <a:r>
-              <a:rPr sz="1100">
-                <a:solidFill>
-                  <a:srgbClr val="FFFFFF"/>
-                </a:solidFill>
-              </a:rPr>
-              <a:t>6.  Joint Terrorism Analysis Centre (JTAC), United Kingdom.</a:t>
-            </a:r>
-          </a:p>
-          <a:p>
-            <a:pPr>
-              <a:spcAft>
-                <a:spcPts val="600"/>
-              </a:spcAft>
-            </a:pPr>
-            <a:r>
-              <a:rPr sz="1100">
-                <a:solidFill>
-                  <a:srgbClr val="FFFFFF"/>
-                </a:solidFill>
-              </a:rPr>
-              <a:t>7.  National Counterterrorism Center (NCTC), United States.</a:t>
-            </a:r>
-          </a:p>
-          <a:p>
-            <a:pPr>
-              <a:spcAft>
-                <a:spcPts val="600"/>
-              </a:spcAft>
-            </a:pPr>
-            <a:r>
-              <a:rPr sz="1100">
-                <a:solidFill>
-                  <a:srgbClr val="FFFFFF"/>
-                </a:solidFill>
-              </a:rPr>
-              <a:t>8.  Multi-Agency Centre (MAC), India — established following the 2008 Mumbai attacks.</a:t>
-            </a:r>
-          </a:p>
-          <a:p>
-            <a:pPr>
-              <a:spcAft>
-                <a:spcPts val="600"/>
-              </a:spcAft>
-            </a:pPr>
-            <a:r>
-              <a:rPr sz="1100">
-                <a:solidFill>
-                  <a:srgbClr val="FFFFFF"/>
-                </a:solidFill>
-              </a:rPr>
-              <a:t>9.  Israel's civil defence rapid-response and pre-positioning doctrine.</a:t>
-            </a:r>
-          </a:p>
-          <a:p>
-            <a:pPr>
-              <a:spcAft>
-                <a:spcPts val="600"/>
-              </a:spcAft>
-            </a:pPr>
-            <a:r>
-              <a:rPr sz="1100">
-                <a:solidFill>
-                  <a:srgbClr val="FFFFFF"/>
-                </a:solidFill>
-              </a:rPr>
-              <a:t>10.  Post-Good Friday Agreement youth reintegration programmes, Northern Ireland.</a:t>
-            </a:r>
-          </a:p>
-          <a:p>
-            <a:pPr>
-              <a:spcAft>
-                <a:spcPts val="600"/>
-              </a:spcAft>
-            </a:pPr>
-            <a:r>
-              <a:rPr sz="1100">
-                <a:solidFill>
-                  <a:srgbClr val="FFFFFF"/>
-                </a:solidFill>
-              </a:rPr>
-              <a:t>11.  Provincial policing powers debate, South Africa.</a:t>
-            </a:r>
-          </a:p>
-          <a:p>
-            <a:pPr>
-              <a:spcAft>
-                <a:spcPts val="600"/>
-              </a:spcAft>
-            </a:pPr>
-            <a:r>
-              <a:rPr sz="1100">
-                <a:solidFill>
-                  <a:srgbClr val="FFFFFF"/>
-                </a:solidFill>
-              </a:rPr>
-              <a:t>12.  Cross-border grazing and pastoralist dialogue initiatives across the Sahel, including the Kenya-Ethiopia grazing corridor agreements.</a:t>
-            </a:r>
-          </a:p>
-          <a:p>
-            <a:pPr>
-              <a:spcAft>
-                <a:spcPts val="600"/>
-              </a:spcAft>
-            </a:pPr>
-            <a:r>
-              <a:rPr sz="1100">
-                <a:solidFill>
-                  <a:srgbClr val="FFFFFF"/>
-                </a:solidFill>
-              </a:rPr>
-              <a:t>13.  North-Central Nigeria Governors' Forum joint security operations agreement, 2025.</a:t>
-            </a:r>
-          </a:p>
-        </p:txBody>
-      </p:sp>
-    </p:spTree>
-  </p:cSld>
-  <p:clrMapOvr>
-    <a:masterClrMapping/>
-  </p:clrMapOvr>
-</p:sld>
-</file>
-
-<file path=ppt/slides/slide29.xml><?xml version="1.0" encoding="utf-8"?>
-<p:sld xmlns:a="http://schemas.openxmlformats.org/drawingml/2006/main" xmlns:p="http://schemas.openxmlformats.org/presentationml/2006/main" xmlns:r="http://schemas.openxmlformats.org/officeDocument/2006/relationships">
-  <p:cSld>
-    <p:spTree>
-      <p:nvGrpSpPr>
-        <p:cNvPr id="1" name=""/>
-        <p:cNvGrpSpPr/>
-        <p:nvPr/>
-      </p:nvGrpSpPr>
-      <p:grpSpPr/>
-      <p:sp>
-        <p:nvSpPr>
-          <p:cNvPr id="2" name="Rectangle 1"/>
-          <p:cNvSpPr/>
-          <p:nvPr/>
-        </p:nvSpPr>
-        <p:spPr>
-          <a:xfrm>
-            <a:off x="0" y="0"/>
-            <a:ext cx="12191695" cy="1051560"/>
-          </a:xfrm>
-          <a:prstGeom prst="rect">
-            <a:avLst/>
-          </a:prstGeom>
-          <a:solidFill>
-            <a:srgbClr val="132C52"/>
-          </a:solidFill>
-          <a:ln>
-            <a:noFill/>
-          </a:ln>
-          <a:effectLst/>
-        </p:spPr>
-        <p:style>
-          <a:lnRef idx="1">
-            <a:schemeClr val="accent1"/>
-          </a:lnRef>
-          <a:fillRef idx="3">
-            <a:schemeClr val="accent1"/>
-          </a:fillRef>
-          <a:effectRef idx="2">
-            <a:schemeClr val="accent1"/>
-          </a:effectRef>
-          <a:fontRef idx="minor">
-            <a:schemeClr val="lt1"/>
-          </a:fontRef>
-        </p:style>
-        <p:txBody>
-          <a:bodyPr rtlCol="0" anchor="ctr"/>
-          <a:lstStyle/>
-          <a:p>
-            <a:pPr algn="ctr"/>
-            <a:endParaRPr/>
-          </a:p>
-        </p:txBody>
-      </p:sp>
-      <p:sp>
-        <p:nvSpPr>
-          <p:cNvPr id="3" name="Rectangle 2"/>
-          <p:cNvSpPr/>
-          <p:nvPr/>
-        </p:nvSpPr>
-        <p:spPr>
-          <a:xfrm>
-            <a:off x="0" y="1051560"/>
-            <a:ext cx="12191695" cy="38100"/>
-          </a:xfrm>
-          <a:prstGeom prst="rect">
-            <a:avLst/>
-          </a:prstGeom>
-          <a:solidFill>
-            <a:srgbClr val="D4AF37"/>
-          </a:solidFill>
-          <a:ln>
-            <a:noFill/>
-          </a:ln>
-          <a:effectLst/>
-        </p:spPr>
-        <p:style>
-          <a:lnRef idx="1">
-            <a:schemeClr val="accent1"/>
-          </a:lnRef>
-          <a:fillRef idx="3">
-            <a:schemeClr val="accent1"/>
-          </a:fillRef>
-          <a:effectRef idx="2">
-            <a:schemeClr val="accent1"/>
-          </a:effectRef>
-          <a:fontRef idx="minor">
-            <a:schemeClr val="lt1"/>
-          </a:fontRef>
-        </p:style>
-        <p:txBody>
-          <a:bodyPr rtlCol="0" anchor="ctr"/>
-          <a:lstStyle/>
-          <a:p>
-            <a:pPr algn="ctr"/>
-            <a:endParaRPr/>
-          </a:p>
-        </p:txBody>
-      </p:sp>
-      <p:sp>
-        <p:nvSpPr>
-          <p:cNvPr id="4" name="TextBox 3"/>
-          <p:cNvSpPr txBox="1"/>
-          <p:nvPr/>
-        </p:nvSpPr>
-        <p:spPr>
-          <a:xfrm>
-            <a:off x="457200" y="73152"/>
-            <a:ext cx="9144000" cy="320040"/>
-          </a:xfrm>
-          <a:prstGeom prst="rect">
-            <a:avLst/>
-          </a:prstGeom>
-          <a:noFill/>
-        </p:spPr>
-        <p:txBody>
-          <a:bodyPr wrap="square" anchor="t">
-            <a:spAutoFit/>
-          </a:bodyPr>
-          <a:lstStyle/>
-          <a:p>
-            <a:pPr algn="l">
-              <a:lnSpc>
-                <a:spcPct val="110000"/>
-              </a:lnSpc>
-            </a:pPr>
-            <a:r>
-              <a:rPr sz="2000" b="1" i="0">
-                <a:solidFill>
-                  <a:srgbClr val="D4AF37"/>
-                </a:solidFill>
-                <a:latin typeface="Calibri"/>
-              </a:rPr>
-              <a:t>APPENDIX</a:t>
-            </a:r>
-          </a:p>
-        </p:txBody>
-      </p:sp>
-      <p:sp>
-        <p:nvSpPr>
-          <p:cNvPr id="5" name="TextBox 4"/>
-          <p:cNvSpPr txBox="1"/>
-          <p:nvPr/>
-        </p:nvSpPr>
-        <p:spPr>
-          <a:xfrm>
-            <a:off x="457200" y="365760"/>
-            <a:ext cx="10515600" cy="594360"/>
-          </a:xfrm>
-          <a:prstGeom prst="rect">
-            <a:avLst/>
-          </a:prstGeom>
-          <a:noFill/>
-        </p:spPr>
-        <p:txBody>
-          <a:bodyPr wrap="square" anchor="t">
-            <a:spAutoFit/>
-          </a:bodyPr>
-          <a:lstStyle/>
-          <a:p>
-            <a:pPr algn="l">
-              <a:lnSpc>
-                <a:spcPct val="110000"/>
-              </a:lnSpc>
-            </a:pPr>
-            <a:r>
-              <a:rPr sz="2600" b="1" i="0">
-                <a:solidFill>
-                  <a:srgbClr val="FFFFFF"/>
-                </a:solidFill>
-                <a:latin typeface="Calibri"/>
-              </a:rPr>
-              <a:t>References (Harvard Style)</a:t>
-            </a:r>
-          </a:p>
-        </p:txBody>
-      </p:sp>
-      <p:sp>
-        <p:nvSpPr>
-          <p:cNvPr id="6" name="TextBox 5"/>
-          <p:cNvSpPr txBox="1"/>
-          <p:nvPr/>
-        </p:nvSpPr>
-        <p:spPr>
-          <a:xfrm>
-            <a:off x="11247120" y="384048"/>
-            <a:ext cx="731520" cy="457200"/>
-          </a:xfrm>
-          <a:prstGeom prst="rect">
-            <a:avLst/>
-          </a:prstGeom>
-          <a:noFill/>
-        </p:spPr>
-        <p:txBody>
-          <a:bodyPr wrap="square" anchor="t">
-            <a:spAutoFit/>
-          </a:bodyPr>
-          <a:lstStyle/>
-          <a:p>
-            <a:pPr algn="r">
-              <a:lnSpc>
-                <a:spcPct val="110000"/>
-              </a:lnSpc>
-            </a:pPr>
-            <a:r>
-              <a:rPr sz="2000" b="1" i="0">
-                <a:solidFill>
-                  <a:srgbClr val="D4AF37"/>
-                </a:solidFill>
-                <a:latin typeface="Calibri"/>
-              </a:rPr>
-              <a:t>29</a:t>
-            </a:r>
-          </a:p>
-        </p:txBody>
-      </p:sp>
-      <p:sp>
-        <p:nvSpPr>
-          <p:cNvPr id="7" name="TextBox 6"/>
-          <p:cNvSpPr txBox="1"/>
-          <p:nvPr/>
-        </p:nvSpPr>
-        <p:spPr>
-          <a:xfrm>
-            <a:off x="457200" y="6537960"/>
-            <a:ext cx="5486400" cy="274320"/>
-          </a:xfrm>
-          <a:prstGeom prst="rect">
-            <a:avLst/>
-          </a:prstGeom>
-          <a:noFill/>
-        </p:spPr>
-        <p:txBody>
-          <a:bodyPr wrap="square" anchor="t">
-            <a:spAutoFit/>
-          </a:bodyPr>
-          <a:lstStyle/>
-          <a:p>
-            <a:pPr algn="l">
-              <a:lnSpc>
-                <a:spcPct val="110000"/>
-              </a:lnSpc>
-            </a:pPr>
-            <a:r>
-              <a:rPr sz="2000" b="0" i="0">
-                <a:solidFill>
-                  <a:srgbClr val="9AA5B1"/>
-                </a:solidFill>
-                <a:latin typeface="Calibri"/>
-              </a:rPr>
-              <a:t>AVM Monday Riku Morgan (Rtd) — North-Central Security Summit</a:t>
-            </a:r>
-          </a:p>
-        </p:txBody>
-      </p:sp>
-      <p:sp>
-        <p:nvSpPr>
-          <p:cNvPr id="8" name="TextBox 7"/>
-          <p:cNvSpPr txBox="1"/>
-          <p:nvPr/>
-        </p:nvSpPr>
-        <p:spPr>
-          <a:xfrm>
-            <a:off x="10515600" y="6537960"/>
-            <a:ext cx="1280160" cy="274320"/>
-          </a:xfrm>
-          <a:prstGeom prst="rect">
-            <a:avLst/>
-          </a:prstGeom>
-          <a:noFill/>
-        </p:spPr>
-        <p:txBody>
-          <a:bodyPr wrap="square" anchor="t">
-            <a:spAutoFit/>
-          </a:bodyPr>
-          <a:lstStyle/>
-          <a:p>
-            <a:pPr algn="r">
-              <a:lnSpc>
-                <a:spcPct val="110000"/>
-              </a:lnSpc>
-            </a:pPr>
-            <a:r>
-              <a:rPr sz="2000" b="0" i="0">
-                <a:solidFill>
-                  <a:srgbClr val="9AA5B1"/>
-                </a:solidFill>
-                <a:latin typeface="Calibri"/>
-              </a:rPr>
-              <a:t>29 / 29</a:t>
+              <a:t>28 / 28</a:t>
             </a:r>
           </a:p>
         </p:txBody>

</xml_diff>

<commit_message>
Fix slide 28: restore dark navy background (was missing, causing invisible white text)
</commit_message>
<xml_diff>
--- a/documents_aug2026/AVM_MORGAN_SECURITY_KEYNOTE_30MIN.pptx
+++ b/documents_aug2026/AVM_MORGAN_SECURITY_KEYNOTE_30MIN.pptx
@@ -17389,6 +17389,14 @@
 <file path=ppt/slides/slide28.xml><?xml version="1.0" encoding="utf-8"?>
 <p:sld xmlns:a="http://schemas.openxmlformats.org/drawingml/2006/main" xmlns:p="http://schemas.openxmlformats.org/presentationml/2006/main" xmlns:r="http://schemas.openxmlformats.org/officeDocument/2006/relationships">
   <p:cSld>
+    <p:bg>
+      <p:bgPr>
+        <a:solidFill>
+          <a:srgbClr val="0B1F3A"/>
+        </a:solidFill>
+        <a:effectLst/>
+      </p:bgPr>
+    </p:bg>
     <p:spTree>
       <p:nvGrpSpPr>
         <p:cNvPr id="1" name=""/>

</xml_diff>